<commit_message>
Deck: fix two defects found by actually rendering it
PowerPoint is installed on this machine, so the slides could be exported
to PNG via COM and looked at - the visual QA I said I could not do when
the deck first landed. Both defects were real and neither showed up in
the structural or geometry checks.

Slide 7: the stat blocks were pinned to the top of their dark cards,
leaving an obvious void under 19% and 31. Centred in the card.

Slide 5: a horizontal bar chart plots its first category at the BOTTOM,
so the accuracy chart read worst-first from the top. Arrays reversed, and
the grey highlight moved with its bar so the transformer average stays
the muted one.

Everything else renders clean: no overflow, no collisions, native chart
intact, and the roughly one-inch bottom margin is consistent across all
ten slides rather than uneven.
</commit_message>
<xml_diff>
--- a/docs/defense_deck.pptx
+++ b/docs/defense_deck.pptx
@@ -190,7 +190,7 @@
             <c:bubble3D val="0"/>
             <c:spPr>
               <a:solidFill>
-                <a:srgbClr val="4B7F96"/>
+                <a:srgbClr val="AEC3CD"/>
               </a:solidFill>
               <a:effectLst/>
             </c:spPr>
@@ -201,7 +201,7 @@
             <c:bubble3D val="0"/>
             <c:spPr>
               <a:solidFill>
-                <a:srgbClr val="AEC3CD"/>
+                <a:srgbClr val="4B7F96"/>
               </a:solidFill>
               <a:effectLst/>
             </c:spPr>
@@ -224,16 +224,16 @@
                 <c:ptCount val="4"/>
                 <c:lvl>
                   <c:pt idx="0">
-                    <c:v>LLM (haiku)</c:v>
+                    <c:v>DictaBERT — HE</c:v>
                   </c:pt>
                   <c:pt idx="1">
+                    <c:v>Transformers avg</c:v>
+                  </c:pt>
+                  <c:pt idx="2">
                     <c:v>FinBERT — EN</c:v>
                   </c:pt>
-                  <c:pt idx="2">
-                    <c:v>Transformers avg</c:v>
-                  </c:pt>
                   <c:pt idx="3">
-                    <c:v>DictaBERT — HE</c:v>
+                    <c:v>LLM (haiku)</c:v>
                   </c:pt>
                 </c:lvl>
               </c:multiLvlStrCache>
@@ -246,16 +246,16 @@
                 <c:formatCode>General</c:formatCode>
                 <c:ptCount val="4"/>
                 <c:pt idx="0">
-                  <c:v>0.9</c:v>
+                  <c:v>0.7</c:v>
                 </c:pt>
                 <c:pt idx="1">
+                  <c:v>0.77</c:v>
+                </c:pt>
+                <c:pt idx="2">
                   <c:v>0.8</c:v>
                 </c:pt>
-                <c:pt idx="2">
-                  <c:v>0.77</c:v>
-                </c:pt>
                 <c:pt idx="3">
-                  <c:v>0.7</c:v>
+                  <c:v>0.9</c:v>
                 </c:pt>
               </c:numCache>
             </c:numRef>
@@ -7133,7 +7133,7 @@
         </p:nvSpPr>
         <p:spPr>
           <a:xfrm>
-            <a:off x="6766560" y="1847088"/>
+            <a:off x="6766560" y="2002536"/>
             <a:ext cx="2281428" cy="658368"/>
           </a:xfrm>
           <a:prstGeom prst="rect">
@@ -7172,7 +7172,7 @@
         </p:nvSpPr>
         <p:spPr>
           <a:xfrm>
-            <a:off x="6766560" y="2523744"/>
+            <a:off x="6766560" y="2679192"/>
             <a:ext cx="2281428" cy="475488"/>
           </a:xfrm>
           <a:prstGeom prst="rect">
@@ -7261,7 +7261,7 @@
         </p:nvSpPr>
         <p:spPr>
           <a:xfrm>
-            <a:off x="9340596" y="1847088"/>
+            <a:off x="9340596" y="2002536"/>
             <a:ext cx="2281428" cy="658368"/>
           </a:xfrm>
           <a:prstGeom prst="rect">
@@ -7300,7 +7300,7 @@
         </p:nvSpPr>
         <p:spPr>
           <a:xfrm>
-            <a:off x="9340596" y="2523744"/>
+            <a:off x="9340596" y="2679192"/>
             <a:ext cx="2281428" cy="475488"/>
           </a:xfrm>
           <a:prstGeom prst="rect">

</xml_diff>